<commit_message>
docs: sync all docs to deployed 3-model ensemble (val 0.840, fresh holdout 0.844); fix refs slide
</commit_message>
<xml_diff>
--- a/ppt/SynCura_Deck_V2.pptx
+++ b/ppt/SynCura_Deck_V2.pptx
@@ -3671,14 +3671,6 @@
               <a:buChar char="•"/>
             </a:pPr>
             <a:r>
-              <a:rPr lang="en-US" sz="1450" dirty="0">
-                <a:solidFill>
-                  <a:srgbClr val="000000"/>
-                </a:solidFill>
-                <a:latin typeface="Times New Roman" pitchFamily="34" charset="0"/>
-                <a:ea typeface="Times New Roman" pitchFamily="34" charset="-122"/>
-                <a:cs typeface="Times New Roman" pitchFamily="34" charset="-120"/>
-              </a:rPr>
               <a:t>[1] Y. Wang, Y. Bai, and G. Jin, Explainable Deep-Learning Models..., Frontiers in Physiology, vol. 17, 2026.</a:t>
             </a:r>
             <a:endParaRPr sz="1450"/>
@@ -3695,14 +3687,6 @@
               <a:buChar char="•"/>
             </a:pPr>
             <a:r>
-              <a:rPr lang="en-US" sz="1450" dirty="0">
-                <a:solidFill>
-                  <a:srgbClr val="000000"/>
-                </a:solidFill>
-                <a:latin typeface="Times New Roman" pitchFamily="34" charset="0"/>
-                <a:ea typeface="Times New Roman" pitchFamily="34" charset="-122"/>
-                <a:cs typeface="Times New Roman" pitchFamily="34" charset="-120"/>
-              </a:rPr>
               <a:t>[2] Z. Yan et al., Deep learning-based in-hospital mortality prediction..., PeerJ, vol. 14, e21631, 2026.</a:t>
             </a:r>
             <a:endParaRPr sz="1450"/>
@@ -3719,14 +3703,6 @@
               <a:buChar char="•"/>
             </a:pPr>
             <a:r>
-              <a:rPr lang="en-US" sz="1450" dirty="0">
-                <a:solidFill>
-                  <a:srgbClr val="000000"/>
-                </a:solidFill>
-                <a:latin typeface="Times New Roman" pitchFamily="34" charset="0"/>
-                <a:ea typeface="Times New Roman" pitchFamily="34" charset="-122"/>
-                <a:cs typeface="Times New Roman" pitchFamily="34" charset="-120"/>
-              </a:rPr>
               <a:t>[3] B. Sadanandan, Multimodal Deep Learning for Early Prediction..., arXiv:2603.14719, 2026.</a:t>
             </a:r>
             <a:endParaRPr sz="1450"/>
@@ -3743,14 +3719,6 @@
               <a:buChar char="•"/>
             </a:pPr>
             <a:r>
-              <a:rPr lang="en-US" sz="1450" dirty="0">
-                <a:solidFill>
-                  <a:srgbClr val="000000"/>
-                </a:solidFill>
-                <a:latin typeface="Times New Roman" pitchFamily="34" charset="0"/>
-                <a:ea typeface="Times New Roman" pitchFamily="34" charset="-122"/>
-                <a:cs typeface="Times New Roman" pitchFamily="34" charset="-120"/>
-              </a:rPr>
               <a:t>[4] Y. Wu et al., Revisiting the potential value of vital signs..., Journal of Big Data, vol. 11, no. 40, 2024.</a:t>
             </a:r>
             <a:endParaRPr sz="1450"/>
@@ -3767,15 +3735,7 @@
               <a:buChar char="•"/>
             </a:pPr>
             <a:r>
-              <a:rPr lang="en-US" sz="1450" dirty="0">
-                <a:solidFill>
-                  <a:srgbClr val="000000"/>
-                </a:solidFill>
-                <a:latin typeface="Times New Roman" pitchFamily="34" charset="0"/>
-                <a:ea typeface="Times New Roman" pitchFamily="34" charset="-122"/>
-                <a:cs typeface="Times New Roman" pitchFamily="34" charset="-120"/>
-              </a:rPr>
-              <a:t>[5] M. Nguyen et al., Deep Learning to Attend to Risk in ICU, arXiv:1707.05010, 2017.</a:t>
+              <a:t>[5] P. Xie et al., Unlocking real-time ICU mortality prediction..., npj Digital Medicine, vol. 8, 733, 2025.</a:t>
             </a:r>
             <a:endParaRPr sz="1450"/>
           </a:p>
@@ -3791,15 +3751,7 @@
               <a:buChar char="•"/>
             </a:pPr>
             <a:r>
-              <a:rPr lang="en-US" sz="1450" dirty="0">
-                <a:solidFill>
-                  <a:srgbClr val="000000"/>
-                </a:solidFill>
-                <a:latin typeface="Times New Roman" pitchFamily="34" charset="0"/>
-                <a:ea typeface="Times New Roman" pitchFamily="34" charset="-122"/>
-                <a:cs typeface="Times New Roman" pitchFamily="34" charset="-120"/>
-              </a:rPr>
-              <a:t>[6] P. Xie et al., Unlocking real-time ICU mortality prediction..., npj Digital Medicine, vol. 8, 733, 2025.</a:t>
+              <a:t>[6] E. Choi et al., Deep Interpretable Early Warning System..., IEEE JBHI, vol. 24, no. 9, 2020.</a:t>
             </a:r>
             <a:endParaRPr sz="1450"/>
           </a:p>
@@ -3815,15 +3767,7 @@
               <a:buChar char="•"/>
             </a:pPr>
             <a:r>
-              <a:rPr lang="en-US" sz="1450" dirty="0">
-                <a:solidFill>
-                  <a:srgbClr val="000000"/>
-                </a:solidFill>
-                <a:latin typeface="Times New Roman" pitchFamily="34" charset="0"/>
-                <a:ea typeface="Times New Roman" pitchFamily="34" charset="-122"/>
-                <a:cs typeface="Times New Roman" pitchFamily="34" charset="-120"/>
-              </a:rPr>
-              <a:t>[7] E. Choi et al., Deep Interpretable Early Warning System..., IEEE JBHI, vol. 24, no. 9, 2020.</a:t>
+              <a:t>[7] M. R. Scheid et al., Clinical wearable deep learning based deterioration prediction..., Nature Communications, vol. 16, 9513, 2025.</a:t>
             </a:r>
             <a:endParaRPr sz="1450"/>
           </a:p>
@@ -3839,63 +3783,7 @@
               <a:buChar char="•"/>
             </a:pPr>
             <a:r>
-              <a:rPr lang="en-US" sz="1450" dirty="0">
-                <a:solidFill>
-                  <a:srgbClr val="000000"/>
-                </a:solidFill>
-                <a:latin typeface="Times New Roman" pitchFamily="34" charset="0"/>
-                <a:ea typeface="Times New Roman" pitchFamily="34" charset="-122"/>
-                <a:cs typeface="Times New Roman" pitchFamily="34" charset="-120"/>
-              </a:rPr>
-              <a:t>[8] T. C. Do et al., Rapid Response System Based on Graph Attention Network..., IEEE Access, vol. 11, 2023.</a:t>
-            </a:r>
-            <a:endParaRPr sz="1450"/>
-          </a:p>
-          <a:p>
-            <a:pPr marL="406400" indent="-406400">
-              <a:lnSpc>
-                <a:spcPct val="150000"/>
-              </a:lnSpc>
-              <a:spcAft>
-                <a:spcPts val="1400"/>
-              </a:spcAft>
-              <a:buSzPct val="100000"/>
-              <a:buChar char="•"/>
-            </a:pPr>
-            <a:r>
-              <a:rPr lang="en-US" sz="1450" dirty="0">
-                <a:solidFill>
-                  <a:srgbClr val="000000"/>
-                </a:solidFill>
-                <a:latin typeface="Times New Roman" pitchFamily="34" charset="0"/>
-                <a:ea typeface="Times New Roman" pitchFamily="34" charset="-122"/>
-                <a:cs typeface="Times New Roman" pitchFamily="34" charset="-120"/>
-              </a:rPr>
-              <a:t>[9] M. R. Scheid et al., Clinical wearable deep learning based deterioration prediction..., Nature Communications, vol. 16, 9513, 2025.</a:t>
-            </a:r>
-            <a:endParaRPr sz="1450"/>
-          </a:p>
-          <a:p>
-            <a:pPr marL="406400" indent="-406400">
-              <a:lnSpc>
-                <a:spcPct val="150000"/>
-              </a:lnSpc>
-              <a:spcAft>
-                <a:spcPts val="1400"/>
-              </a:spcAft>
-              <a:buSzPct val="100000"/>
-              <a:buChar char="•"/>
-            </a:pPr>
-            <a:r>
-              <a:rPr lang="en-US" sz="1450" dirty="0">
-                <a:solidFill>
-                  <a:srgbClr val="000000"/>
-                </a:solidFill>
-                <a:latin typeface="Times New Roman" pitchFamily="34" charset="0"/>
-                <a:ea typeface="Times New Roman" pitchFamily="34" charset="-122"/>
-                <a:cs typeface="Times New Roman" pitchFamily="34" charset="-120"/>
-              </a:rPr>
-              <a:t>[10] PhysioNet, Computing in Cardiology Challenge 2012, physionet.org/content/challenge-2012/.</a:t>
+              <a:t>[8] PhysioNet, Computing in Cardiology Challenge 2012, physionet.org/content/challenge-2012/.</a:t>
             </a:r>
             <a:endParaRPr sz="1450"/>
           </a:p>
@@ -5560,7 +5448,7 @@
                 </a:solidFill>
                 <a:latin typeface="Times New Roman"/>
               </a:rPr>
-              <a:t>Different/better - evidence: unseen set-B holdout (4,000 patients) AUC 0.844 exceeds validation AUC 0.840.</a:t>
+              <a:t>Different/better - evidence: fresh unseen 20% set-B holdout AUC 0.844 exceeds validation AUC 0.840.</a:t>
             </a:r>
           </a:p>
           <a:p>
@@ -6344,7 +6232,7 @@
                 </a:solidFill>
                 <a:latin typeface="Times New Roman"/>
               </a:rPr>
-              <a:t>Deployed ensemble: 0.840 validation AUC and 0.844 AUC on the unseen set-B holdout of 4,000 patients.</a:t>
+              <a:t>Deployed ensemble: 0.840 validation AUC and 0.844 AUC on the fresh unseen 20% set-B holdout.</a:t>
             </a:r>
             <a:endParaRPr sz="2100"/>
           </a:p>

</xml_diff>

<commit_message>
docs: add mistake-driven retraining loop to solution, script, report and talking points
</commit_message>
<xml_diff>
--- a/ppt/SynCura_Deck_V2.pptx
+++ b/ppt/SynCura_Deck_V2.pptx
@@ -5463,6 +5463,18 @@
               <a:t>Different/better - deployment: an end-to-end FastAPI serving path, alerts, and HTTP and MQTT ingestion - not just a trained model.</a:t>
             </a:r>
           </a:p>
+          <a:p>
+            <a:pPr/>
+            <a:r>
+              <a:rPr sz="2100">
+                <a:solidFill>
+                  <a:srgbClr val="000000"/>
+                </a:solidFill>
+                <a:latin typeface="Times New Roman"/>
+              </a:rPr>
+              <a:t>Different/better - learns from mistakes: confirmed misses/false alarms queue into weighted retraining.</a:t>
+            </a:r>
+          </a:p>
         </p:txBody>
       </p:sp>
     </p:spTree>

</xml_diff>

<commit_message>
feat: methodology slide flowchart (5-step pipeline) replaces text bullets
</commit_message>
<xml_diff>
--- a/ppt/SynCura_Deck_V2.pptx
+++ b/ppt/SynCura_Deck_V2.pptx
@@ -6525,14 +6525,541 @@
       </p:sp>
       <p:sp>
         <p:nvSpPr>
-          <p:cNvPr id="6" name="TextBox 5"/>
+          <p:cNvPr id="6" name="Rounded Rectangle 5"/>
+          <p:cNvSpPr/>
+          <p:nvPr/>
+        </p:nvSpPr>
+        <p:spPr>
+          <a:xfrm>
+            <a:off x="1051560" y="3977639"/>
+            <a:ext cx="2606040" cy="2148840"/>
+          </a:xfrm>
+          <a:prstGeom prst="roundRect">
+            <a:avLst/>
+          </a:prstGeom>
+          <a:solidFill>
+            <a:srgbClr val="FFFFFF"/>
+          </a:solidFill>
+          <a:ln w="28575">
+            <a:solidFill>
+              <a:srgbClr val="1757AC"/>
+            </a:solidFill>
+          </a:ln>
+        </p:spPr>
+        <p:style>
+          <a:lnRef idx="1">
+            <a:schemeClr val="accent1"/>
+          </a:lnRef>
+          <a:fillRef idx="3">
+            <a:schemeClr val="accent1"/>
+          </a:fillRef>
+          <a:effectRef idx="2">
+            <a:schemeClr val="accent1"/>
+          </a:effectRef>
+          <a:fontRef idx="minor">
+            <a:schemeClr val="lt1"/>
+          </a:fontRef>
+        </p:style>
+        <p:txBody>
+          <a:bodyPr rtlCol="0" anchor="ctr" wrap="square"/>
+          <a:lstStyle/>
+          <a:p>
+            <a:pPr algn="ctr"/>
+            <a:r>
+              <a:rPr sz="2000" b="1">
+                <a:solidFill>
+                  <a:srgbClr val="1757AC"/>
+                </a:solidFill>
+                <a:latin typeface="Times New Roman"/>
+              </a:rPr>
+              <a:t>1 · DATA</a:t>
+            </a:r>
+          </a:p>
+          <a:p>
+            <a:pPr algn="ctr">
+              <a:spcBef>
+                <a:spcPts val="600"/>
+              </a:spcBef>
+            </a:pPr>
+            <a:r>
+              <a:rPr sz="1500">
+                <a:solidFill>
+                  <a:srgbClr val="000000"/>
+                </a:solidFill>
+                <a:latin typeface="Times New Roman"/>
+              </a:rPr>
+              <a:t>PhysioNet 2012
+12 vitals + labs</a:t>
+            </a:r>
+          </a:p>
+        </p:txBody>
+      </p:sp>
+      <p:sp>
+        <p:nvSpPr>
+          <p:cNvPr id="7" name="Right Arrow 6"/>
+          <p:cNvSpPr/>
+          <p:nvPr/>
+        </p:nvSpPr>
+        <p:spPr>
+          <a:xfrm>
+            <a:off x="3712464" y="4850892"/>
+            <a:ext cx="457200" cy="402336"/>
+          </a:xfrm>
+          <a:prstGeom prst="rightArrow">
+            <a:avLst/>
+          </a:prstGeom>
+          <a:solidFill>
+            <a:srgbClr val="1757AC"/>
+          </a:solidFill>
+          <a:ln>
+            <a:noFill/>
+          </a:ln>
+        </p:spPr>
+        <p:style>
+          <a:lnRef idx="1">
+            <a:schemeClr val="accent1"/>
+          </a:lnRef>
+          <a:fillRef idx="3">
+            <a:schemeClr val="accent1"/>
+          </a:fillRef>
+          <a:effectRef idx="2">
+            <a:schemeClr val="accent1"/>
+          </a:effectRef>
+          <a:fontRef idx="minor">
+            <a:schemeClr val="lt1"/>
+          </a:fontRef>
+        </p:style>
+        <p:txBody>
+          <a:bodyPr rtlCol="0" anchor="ctr"/>
+          <a:lstStyle/>
+          <a:p>
+            <a:pPr algn="ctr"/>
+          </a:p>
+        </p:txBody>
+      </p:sp>
+      <p:sp>
+        <p:nvSpPr>
+          <p:cNvPr id="8" name="Rounded Rectangle 7"/>
+          <p:cNvSpPr/>
+          <p:nvPr/>
+        </p:nvSpPr>
+        <p:spPr>
+          <a:xfrm>
+            <a:off x="4224528" y="3977639"/>
+            <a:ext cx="2606040" cy="2148840"/>
+          </a:xfrm>
+          <a:prstGeom prst="roundRect">
+            <a:avLst/>
+          </a:prstGeom>
+          <a:solidFill>
+            <a:srgbClr val="FFFFFF"/>
+          </a:solidFill>
+          <a:ln w="28575">
+            <a:solidFill>
+              <a:srgbClr val="1757AC"/>
+            </a:solidFill>
+          </a:ln>
+        </p:spPr>
+        <p:style>
+          <a:lnRef idx="1">
+            <a:schemeClr val="accent1"/>
+          </a:lnRef>
+          <a:fillRef idx="3">
+            <a:schemeClr val="accent1"/>
+          </a:fillRef>
+          <a:effectRef idx="2">
+            <a:schemeClr val="accent1"/>
+          </a:effectRef>
+          <a:fontRef idx="minor">
+            <a:schemeClr val="lt1"/>
+          </a:fontRef>
+        </p:style>
+        <p:txBody>
+          <a:bodyPr rtlCol="0" anchor="ctr" wrap="square"/>
+          <a:lstStyle/>
+          <a:p>
+            <a:pPr algn="ctr"/>
+            <a:r>
+              <a:rPr sz="2000" b="1">
+                <a:solidFill>
+                  <a:srgbClr val="1757AC"/>
+                </a:solidFill>
+                <a:latin typeface="Times New Roman"/>
+              </a:rPr>
+              <a:t>2 · PREPARE</a:t>
+            </a:r>
+          </a:p>
+          <a:p>
+            <a:pPr algn="ctr">
+              <a:spcBef>
+                <a:spcPts val="600"/>
+              </a:spcBef>
+            </a:pPr>
+            <a:r>
+              <a:rPr sz="1500">
+                <a:solidFill>
+                  <a:srgbClr val="000000"/>
+                </a:solidFill>
+                <a:latin typeface="Times New Roman"/>
+              </a:rPr>
+              <a:t>Interpolate
+Train-only z-score</a:t>
+            </a:r>
+          </a:p>
+        </p:txBody>
+      </p:sp>
+      <p:sp>
+        <p:nvSpPr>
+          <p:cNvPr id="9" name="Right Arrow 8"/>
+          <p:cNvSpPr/>
+          <p:nvPr/>
+        </p:nvSpPr>
+        <p:spPr>
+          <a:xfrm>
+            <a:off x="6885432" y="4850892"/>
+            <a:ext cx="457200" cy="402336"/>
+          </a:xfrm>
+          <a:prstGeom prst="rightArrow">
+            <a:avLst/>
+          </a:prstGeom>
+          <a:solidFill>
+            <a:srgbClr val="1757AC"/>
+          </a:solidFill>
+          <a:ln>
+            <a:noFill/>
+          </a:ln>
+        </p:spPr>
+        <p:style>
+          <a:lnRef idx="1">
+            <a:schemeClr val="accent1"/>
+          </a:lnRef>
+          <a:fillRef idx="3">
+            <a:schemeClr val="accent1"/>
+          </a:fillRef>
+          <a:effectRef idx="2">
+            <a:schemeClr val="accent1"/>
+          </a:effectRef>
+          <a:fontRef idx="minor">
+            <a:schemeClr val="lt1"/>
+          </a:fontRef>
+        </p:style>
+        <p:txBody>
+          <a:bodyPr rtlCol="0" anchor="ctr"/>
+          <a:lstStyle/>
+          <a:p>
+            <a:pPr algn="ctr"/>
+          </a:p>
+        </p:txBody>
+      </p:sp>
+      <p:sp>
+        <p:nvSpPr>
+          <p:cNvPr id="10" name="Rounded Rectangle 9"/>
+          <p:cNvSpPr/>
+          <p:nvPr/>
+        </p:nvSpPr>
+        <p:spPr>
+          <a:xfrm>
+            <a:off x="7397496" y="3977639"/>
+            <a:ext cx="2606040" cy="2148840"/>
+          </a:xfrm>
+          <a:prstGeom prst="roundRect">
+            <a:avLst/>
+          </a:prstGeom>
+          <a:solidFill>
+            <a:srgbClr val="FFFFFF"/>
+          </a:solidFill>
+          <a:ln w="28575">
+            <a:solidFill>
+              <a:srgbClr val="1757AC"/>
+            </a:solidFill>
+          </a:ln>
+        </p:spPr>
+        <p:style>
+          <a:lnRef idx="1">
+            <a:schemeClr val="accent1"/>
+          </a:lnRef>
+          <a:fillRef idx="3">
+            <a:schemeClr val="accent1"/>
+          </a:fillRef>
+          <a:effectRef idx="2">
+            <a:schemeClr val="accent1"/>
+          </a:effectRef>
+          <a:fontRef idx="minor">
+            <a:schemeClr val="lt1"/>
+          </a:fontRef>
+        </p:style>
+        <p:txBody>
+          <a:bodyPr rtlCol="0" anchor="ctr" wrap="square"/>
+          <a:lstStyle/>
+          <a:p>
+            <a:pPr algn="ctr"/>
+            <a:r>
+              <a:rPr sz="2000" b="1">
+                <a:solidFill>
+                  <a:srgbClr val="1757AC"/>
+                </a:solidFill>
+                <a:latin typeface="Times New Roman"/>
+              </a:rPr>
+              <a:t>3 · WINDOW</a:t>
+            </a:r>
+          </a:p>
+          <a:p>
+            <a:pPr algn="ctr">
+              <a:spcBef>
+                <a:spcPts val="600"/>
+              </a:spcBef>
+            </a:pPr>
+            <a:r>
+              <a:rPr sz="1500">
+                <a:solidFill>
+                  <a:srgbClr val="000000"/>
+                </a:solidFill>
+                <a:latin typeface="Times New Roman"/>
+              </a:rPr>
+              <a:t>90-min rolling
+Stride 15</a:t>
+            </a:r>
+          </a:p>
+        </p:txBody>
+      </p:sp>
+      <p:sp>
+        <p:nvSpPr>
+          <p:cNvPr id="11" name="Right Arrow 10"/>
+          <p:cNvSpPr/>
+          <p:nvPr/>
+        </p:nvSpPr>
+        <p:spPr>
+          <a:xfrm>
+            <a:off x="10058400" y="4850892"/>
+            <a:ext cx="457200" cy="402336"/>
+          </a:xfrm>
+          <a:prstGeom prst="rightArrow">
+            <a:avLst/>
+          </a:prstGeom>
+          <a:solidFill>
+            <a:srgbClr val="1757AC"/>
+          </a:solidFill>
+          <a:ln>
+            <a:noFill/>
+          </a:ln>
+        </p:spPr>
+        <p:style>
+          <a:lnRef idx="1">
+            <a:schemeClr val="accent1"/>
+          </a:lnRef>
+          <a:fillRef idx="3">
+            <a:schemeClr val="accent1"/>
+          </a:fillRef>
+          <a:effectRef idx="2">
+            <a:schemeClr val="accent1"/>
+          </a:effectRef>
+          <a:fontRef idx="minor">
+            <a:schemeClr val="lt1"/>
+          </a:fontRef>
+        </p:style>
+        <p:txBody>
+          <a:bodyPr rtlCol="0" anchor="ctr"/>
+          <a:lstStyle/>
+          <a:p>
+            <a:pPr algn="ctr"/>
+          </a:p>
+        </p:txBody>
+      </p:sp>
+      <p:sp>
+        <p:nvSpPr>
+          <p:cNvPr id="12" name="Rounded Rectangle 11"/>
+          <p:cNvSpPr/>
+          <p:nvPr/>
+        </p:nvSpPr>
+        <p:spPr>
+          <a:xfrm>
+            <a:off x="10570464" y="3977639"/>
+            <a:ext cx="2606040" cy="2148840"/>
+          </a:xfrm>
+          <a:prstGeom prst="roundRect">
+            <a:avLst/>
+          </a:prstGeom>
+          <a:solidFill>
+            <a:srgbClr val="FFFFFF"/>
+          </a:solidFill>
+          <a:ln w="28575">
+            <a:solidFill>
+              <a:srgbClr val="1757AC"/>
+            </a:solidFill>
+          </a:ln>
+        </p:spPr>
+        <p:style>
+          <a:lnRef idx="1">
+            <a:schemeClr val="accent1"/>
+          </a:lnRef>
+          <a:fillRef idx="3">
+            <a:schemeClr val="accent1"/>
+          </a:fillRef>
+          <a:effectRef idx="2">
+            <a:schemeClr val="accent1"/>
+          </a:effectRef>
+          <a:fontRef idx="minor">
+            <a:schemeClr val="lt1"/>
+          </a:fontRef>
+        </p:style>
+        <p:txBody>
+          <a:bodyPr rtlCol="0" anchor="ctr" wrap="square"/>
+          <a:lstStyle/>
+          <a:p>
+            <a:pPr algn="ctr"/>
+            <a:r>
+              <a:rPr sz="2000" b="1">
+                <a:solidFill>
+                  <a:srgbClr val="1757AC"/>
+                </a:solidFill>
+                <a:latin typeface="Times New Roman"/>
+              </a:rPr>
+              <a:t>4 · MODEL</a:t>
+            </a:r>
+          </a:p>
+          <a:p>
+            <a:pPr algn="ctr">
+              <a:spcBef>
+                <a:spcPts val="600"/>
+              </a:spcBef>
+            </a:pPr>
+            <a:r>
+              <a:rPr sz="1500">
+                <a:solidFill>
+                  <a:srgbClr val="000000"/>
+                </a:solidFill>
+                <a:latin typeface="Times New Roman"/>
+              </a:rPr>
+              <a:t>LSTM-96 + attention
+Risk 0–100</a:t>
+            </a:r>
+          </a:p>
+        </p:txBody>
+      </p:sp>
+      <p:sp>
+        <p:nvSpPr>
+          <p:cNvPr id="13" name="Right Arrow 12"/>
+          <p:cNvSpPr/>
+          <p:nvPr/>
+        </p:nvSpPr>
+        <p:spPr>
+          <a:xfrm>
+            <a:off x="13231368" y="4850892"/>
+            <a:ext cx="457200" cy="402336"/>
+          </a:xfrm>
+          <a:prstGeom prst="rightArrow">
+            <a:avLst/>
+          </a:prstGeom>
+          <a:solidFill>
+            <a:srgbClr val="1757AC"/>
+          </a:solidFill>
+          <a:ln>
+            <a:noFill/>
+          </a:ln>
+        </p:spPr>
+        <p:style>
+          <a:lnRef idx="1">
+            <a:schemeClr val="accent1"/>
+          </a:lnRef>
+          <a:fillRef idx="3">
+            <a:schemeClr val="accent1"/>
+          </a:fillRef>
+          <a:effectRef idx="2">
+            <a:schemeClr val="accent1"/>
+          </a:effectRef>
+          <a:fontRef idx="minor">
+            <a:schemeClr val="lt1"/>
+          </a:fontRef>
+        </p:style>
+        <p:txBody>
+          <a:bodyPr rtlCol="0" anchor="ctr"/>
+          <a:lstStyle/>
+          <a:p>
+            <a:pPr algn="ctr"/>
+          </a:p>
+        </p:txBody>
+      </p:sp>
+      <p:sp>
+        <p:nvSpPr>
+          <p:cNvPr id="14" name="Rounded Rectangle 13"/>
+          <p:cNvSpPr/>
+          <p:nvPr/>
+        </p:nvSpPr>
+        <p:spPr>
+          <a:xfrm>
+            <a:off x="13743432" y="3977639"/>
+            <a:ext cx="2606040" cy="2148840"/>
+          </a:xfrm>
+          <a:prstGeom prst="roundRect">
+            <a:avLst/>
+          </a:prstGeom>
+          <a:solidFill>
+            <a:srgbClr val="FFFFFF"/>
+          </a:solidFill>
+          <a:ln w="28575">
+            <a:solidFill>
+              <a:srgbClr val="1757AC"/>
+            </a:solidFill>
+          </a:ln>
+        </p:spPr>
+        <p:style>
+          <a:lnRef idx="1">
+            <a:schemeClr val="accent1"/>
+          </a:lnRef>
+          <a:fillRef idx="3">
+            <a:schemeClr val="accent1"/>
+          </a:fillRef>
+          <a:effectRef idx="2">
+            <a:schemeClr val="accent1"/>
+          </a:effectRef>
+          <a:fontRef idx="minor">
+            <a:schemeClr val="lt1"/>
+          </a:fontRef>
+        </p:style>
+        <p:txBody>
+          <a:bodyPr rtlCol="0" anchor="ctr" wrap="square"/>
+          <a:lstStyle/>
+          <a:p>
+            <a:pPr algn="ctr"/>
+            <a:r>
+              <a:rPr sz="2000" b="1">
+                <a:solidFill>
+                  <a:srgbClr val="1757AC"/>
+                </a:solidFill>
+                <a:latin typeface="Times New Roman"/>
+              </a:rPr>
+              <a:t>5 · SERVE</a:t>
+            </a:r>
+          </a:p>
+          <a:p>
+            <a:pPr algn="ctr">
+              <a:spcBef>
+                <a:spcPts val="600"/>
+              </a:spcBef>
+            </a:pPr>
+            <a:r>
+              <a:rPr sz="1500">
+                <a:solidFill>
+                  <a:srgbClr val="000000"/>
+                </a:solidFill>
+                <a:latin typeface="Times New Roman"/>
+              </a:rPr>
+              <a:t>FastAPI + dashboard
+SHAP explains</a:t>
+            </a:r>
+          </a:p>
+        </p:txBody>
+      </p:sp>
+      <p:sp>
+        <p:nvSpPr>
+          <p:cNvPr id="15" name="TextBox 14"/>
           <p:cNvSpPr txBox="1"/>
           <p:nvPr/>
         </p:nvSpPr>
         <p:spPr>
           <a:xfrm>
-            <a:off x="990295" y="3261665"/>
-            <a:ext cx="16303752" cy="6035040"/>
+            <a:off x="1051560" y="6629400"/>
+            <a:ext cx="15297912" cy="640080"/>
           </a:xfrm>
           <a:prstGeom prst="rect">
             <a:avLst/>
@@ -6540,90 +7067,20 @@
           <a:noFill/>
         </p:spPr>
         <p:txBody>
-          <a:bodyPr wrap="square"/>
-          <a:lstStyle/>
-          <a:p>
-            <a:pPr marL="406400" indent="-406400">
-              <a:lnSpc>
-                <a:spcPct val="150000"/>
-              </a:lnSpc>
-              <a:spcAft>
-                <a:spcPts val="1400"/>
-              </a:spcAft>
-              <a:buSzPct val="100000"/>
-              <a:buChar char="•"/>
-            </a:pPr>
-            <a:r>
-              <a:rPr sz="2000">
-                <a:solidFill>
-                  <a:srgbClr val="000000"/>
-                </a:solidFill>
-                <a:latin typeface="Times New Roman"/>
-              </a:rPr>
-              <a:t>Dataset: PhysioNet 2012 Challenge with 12 features: six vital signs plus GCS, BUN, Creatinine, WBC, Platelets, and Glucose.</a:t>
-            </a:r>
-          </a:p>
-          <a:p>
-            <a:pPr marL="406400" indent="-406400">
-              <a:lnSpc>
-                <a:spcPct val="150000"/>
-              </a:lnSpc>
-              <a:spcAft>
-                <a:spcPts val="1400"/>
-              </a:spcAft>
-              <a:buSzPct val="100000"/>
-              <a:buChar char="•"/>
-            </a:pPr>
-            <a:r>
-              <a:rPr sz="2000">
-                <a:solidFill>
-                  <a:srgbClr val="000000"/>
-                </a:solidFill>
-                <a:latin typeface="Times New Roman"/>
-              </a:rPr>
-              <a:t>Preprocessing: interpolation, train-only population Z-score normalization, 90-minute windows, and 15-minute stride.</a:t>
-            </a:r>
-          </a:p>
-          <a:p>
-            <a:pPr marL="406400" indent="-406400">
-              <a:lnSpc>
-                <a:spcPct val="150000"/>
-              </a:lnSpc>
-              <a:spcAft>
-                <a:spcPts val="1400"/>
-              </a:spcAft>
-              <a:buSzPct val="100000"/>
-              <a:buChar char="•"/>
-            </a:pPr>
-            <a:r>
-              <a:rPr sz="2000">
-                <a:solidFill>
-                  <a:srgbClr val="000000"/>
-                </a:solidFill>
-                <a:latin typeface="Times New Roman"/>
-              </a:rPr>
-              <a:t>Model: two-layer LSTM with hidden size 96, additive temporal attention, dropout, batch normalization, and sigmoid risk output.</a:t>
-            </a:r>
-          </a:p>
-          <a:p>
-            <a:pPr marL="406400" indent="-406400">
-              <a:lnSpc>
-                <a:spcPct val="150000"/>
-              </a:lnSpc>
-              <a:spcAft>
-                <a:spcPts val="1400"/>
-              </a:spcAft>
-              <a:buSzPct val="100000"/>
-              <a:buChar char="•"/>
-            </a:pPr>
-            <a:r>
-              <a:rPr sz="2000">
-                <a:solidFill>
-                  <a:srgbClr val="000000"/>
-                </a:solidFill>
-                <a:latin typeface="Times New Roman"/>
-              </a:rPr>
-              <a:t>Deployment: FastAPI inference and React visualization, with SHAP feature importance and attention-based temporal explanations.</a:t>
+          <a:bodyPr wrap="square">
+            <a:spAutoFit/>
+          </a:bodyPr>
+          <a:lstStyle/>
+          <a:p>
+            <a:pPr algn="ctr"/>
+            <a:r>
+              <a:rPr sz="1500" i="1">
+                <a:solidFill>
+                  <a:srgbClr val="444444"/>
+                </a:solidFill>
+                <a:latin typeface="Times New Roman"/>
+              </a:rPr>
+              <a:t>Leakage controls: train-only stats · patient-level split · past-only windows</a:t>
             </a:r>
           </a:p>
         </p:txBody>

</xml_diff>

<commit_message>
fix: apply dual ratings (ROC+CM evidence, arch strip, full refs, 0.989, roadmap split)
</commit_message>
<xml_diff>
--- a/ppt/SynCura_Deck_V2.pptx
+++ b/ppt/SynCura_Deck_V2.pptx
@@ -3508,7 +3508,7 @@
                 </a:solidFill>
                 <a:latin typeface="Times New Roman"/>
               </a:rPr>
-              <a:t>HOW IT COULD BE BETTER WITH ENOUGH TIME</a:t>
+              <a:t>LIMITATIONS &amp; IMPROVEMENT PATH</a:t>
             </a:r>
           </a:p>
         </p:txBody>
@@ -3550,7 +3550,7 @@
                 </a:solidFill>
                 <a:latin typeface="Times New Roman"/>
               </a:rPr>
-              <a:t>Paper: 0.936 overall, 98.9 at discharge (hindsight); cross-hospital falls to 0.81 / 0.76, no prospective test.</a:t>
+              <a:t>Paper: 0.936, 0.989 at discharge (hindsight); 0.81/0.76 cross-hospital, no bedside test.</a:t>
             </a:r>
           </a:p>
           <a:p>
@@ -3562,7 +3562,7 @@
                 </a:solidFill>
                 <a:latin typeface="Times New Roman"/>
               </a:rPr>
-              <a:t>Real world: US-only retrospective, missing/async vitals, age bias, single-center data.</a:t>
+              <a:t>Reality: US-only retrospective, missing/async vitals, age bias.</a:t>
             </a:r>
           </a:p>
           <a:p>
@@ -3574,7 +3574,7 @@
                 </a:solidFill>
                 <a:latin typeface="Times New Roman"/>
               </a:rPr>
-              <a:t>SynCura stricter: 90-min window only, no future info; unseen holdout 0.844 beats validation 0.840.</a:t>
+              <a:t>Stricter by design: 90-min past-only windows; holdout 0.844 ≥ val 0.840.</a:t>
             </a:r>
           </a:p>
           <a:p>
@@ -3586,7 +3586,7 @@
                 </a:solidFill>
                 <a:latin typeface="Times New Roman"/>
               </a:rPr>
-              <a:t>SynCura reports what papers skip: false alarms, precision, lead time vs NEWS2, calibration.</a:t>
+              <a:t>Reports what papers skip: false alarms, lead time vs NEWS2, calibration.</a:t>
             </a:r>
           </a:p>
           <a:p>
@@ -3598,7 +3598,7 @@
                 </a:solidFill>
                 <a:latin typeface="Times New Roman"/>
               </a:rPr>
-              <a:t>Better-paper path: eICU/MIMIC validation + RealMIP imputation + time-aware attention + pilot.</a:t>
+              <a:t>Path: eICU/MIMIC validation, RealMIP imputation, time-aware attention, pilot.</a:t>
             </a:r>
           </a:p>
         </p:txBody>
@@ -3855,25 +3855,413 @@
               <a:t>Dataset: PhysioNet / Computing in Cardiology Challenge 2012.</a:t>
             </a:r>
           </a:p>
-          <a:p>
-            <a:pPr marL="406400" indent="-406400">
-              <a:lnSpc>
-                <a:spcPct val="150000"/>
-              </a:lnSpc>
-              <a:spcAft>
-                <a:spcPts val="1400"/>
-              </a:spcAft>
-              <a:buSzPct val="100000"/>
-              <a:buChar char="•"/>
+        </p:txBody>
+      </p:sp>
+      <p:sp>
+        <p:nvSpPr>
+          <p:cNvPr id="14" name="Rounded Rectangle 13"/>
+          <p:cNvSpPr/>
+          <p:nvPr/>
+        </p:nvSpPr>
+        <p:spPr>
+          <a:xfrm>
+            <a:off x="1051560" y="6355080"/>
+            <a:ext cx="3246120" cy="2240280"/>
+          </a:xfrm>
+          <a:prstGeom prst="roundRect">
+            <a:avLst/>
+          </a:prstGeom>
+          <a:solidFill>
+            <a:srgbClr val="FFFFFF"/>
+          </a:solidFill>
+          <a:ln w="28575">
+            <a:solidFill>
+              <a:srgbClr val="1757AC"/>
+            </a:solidFill>
+          </a:ln>
+        </p:spPr>
+        <p:style>
+          <a:lnRef idx="1">
+            <a:schemeClr val="accent1"/>
+          </a:lnRef>
+          <a:fillRef idx="3">
+            <a:schemeClr val="accent1"/>
+          </a:fillRef>
+          <a:effectRef idx="2">
+            <a:schemeClr val="accent1"/>
+          </a:effectRef>
+          <a:fontRef idx="minor">
+            <a:schemeClr val="lt1"/>
+          </a:fontRef>
+        </p:style>
+        <p:txBody>
+          <a:bodyPr rtlCol="0" anchor="ctr" wrap="square"/>
+          <a:lstStyle/>
+          <a:p>
+            <a:pPr algn="ctr"/>
+            <a:r>
+              <a:rPr sz="2000" b="1">
+                <a:solidFill>
+                  <a:srgbClr val="1757AC"/>
+                </a:solidFill>
+                <a:latin typeface="Times New Roman"/>
+              </a:rPr>
+              <a:t>SENSE</a:t>
+            </a:r>
+          </a:p>
+          <a:p>
+            <a:pPr algn="ctr">
+              <a:spcBef>
+                <a:spcPts val="600"/>
+              </a:spcBef>
             </a:pPr>
             <a:r>
-              <a:rPr sz="2100">
-                <a:solidFill>
-                  <a:srgbClr val="000000"/>
-                </a:solidFill>
-                <a:latin typeface="Times New Roman"/>
-              </a:rPr>
-              <a:t>SDG relevance: SDG 3 (Good Health and Well-Being) and SDG 9 (Industry, Innovation and Infrastructure).</a:t>
+              <a:rPr sz="1500">
+                <a:solidFill>
+                  <a:srgbClr val="000000"/>
+                </a:solidFill>
+                <a:latin typeface="Times New Roman"/>
+              </a:rPr>
+              <a:t>ESP32 + MAX30105</a:t>
+            </a:r>
+          </a:p>
+        </p:txBody>
+      </p:sp>
+      <p:sp>
+        <p:nvSpPr>
+          <p:cNvPr id="15" name="Right Arrow 14"/>
+          <p:cNvSpPr/>
+          <p:nvPr/>
+        </p:nvSpPr>
+        <p:spPr>
+          <a:xfrm>
+            <a:off x="4370832" y="7274052"/>
+            <a:ext cx="539496" cy="402336"/>
+          </a:xfrm>
+          <a:prstGeom prst="rightArrow">
+            <a:avLst/>
+          </a:prstGeom>
+          <a:solidFill>
+            <a:srgbClr val="1757AC"/>
+          </a:solidFill>
+          <a:ln>
+            <a:noFill/>
+          </a:ln>
+        </p:spPr>
+        <p:style>
+          <a:lnRef idx="1">
+            <a:schemeClr val="accent1"/>
+          </a:lnRef>
+          <a:fillRef idx="3">
+            <a:schemeClr val="accent1"/>
+          </a:fillRef>
+          <a:effectRef idx="2">
+            <a:schemeClr val="accent1"/>
+          </a:effectRef>
+          <a:fontRef idx="minor">
+            <a:schemeClr val="lt1"/>
+          </a:fontRef>
+        </p:style>
+        <p:txBody>
+          <a:bodyPr rtlCol="0" anchor="ctr"/>
+          <a:lstStyle/>
+          <a:p>
+            <a:pPr algn="ctr"/>
+          </a:p>
+        </p:txBody>
+      </p:sp>
+      <p:sp>
+        <p:nvSpPr>
+          <p:cNvPr id="16" name="Rounded Rectangle 15"/>
+          <p:cNvSpPr/>
+          <p:nvPr/>
+        </p:nvSpPr>
+        <p:spPr>
+          <a:xfrm>
+            <a:off x="4983480" y="6355080"/>
+            <a:ext cx="3246120" cy="2240280"/>
+          </a:xfrm>
+          <a:prstGeom prst="roundRect">
+            <a:avLst/>
+          </a:prstGeom>
+          <a:solidFill>
+            <a:srgbClr val="FFFFFF"/>
+          </a:solidFill>
+          <a:ln w="28575">
+            <a:solidFill>
+              <a:srgbClr val="1757AC"/>
+            </a:solidFill>
+          </a:ln>
+        </p:spPr>
+        <p:style>
+          <a:lnRef idx="1">
+            <a:schemeClr val="accent1"/>
+          </a:lnRef>
+          <a:fillRef idx="3">
+            <a:schemeClr val="accent1"/>
+          </a:fillRef>
+          <a:effectRef idx="2">
+            <a:schemeClr val="accent1"/>
+          </a:effectRef>
+          <a:fontRef idx="minor">
+            <a:schemeClr val="lt1"/>
+          </a:fontRef>
+        </p:style>
+        <p:txBody>
+          <a:bodyPr rtlCol="0" anchor="ctr" wrap="square"/>
+          <a:lstStyle/>
+          <a:p>
+            <a:pPr algn="ctr"/>
+            <a:r>
+              <a:rPr sz="2000" b="1">
+                <a:solidFill>
+                  <a:srgbClr val="1757AC"/>
+                </a:solidFill>
+                <a:latin typeface="Times New Roman"/>
+              </a:rPr>
+              <a:t>INGEST</a:t>
+            </a:r>
+          </a:p>
+          <a:p>
+            <a:pPr algn="ctr">
+              <a:spcBef>
+                <a:spcPts val="600"/>
+              </a:spcBef>
+            </a:pPr>
+            <a:r>
+              <a:rPr sz="1500">
+                <a:solidFill>
+                  <a:srgbClr val="000000"/>
+                </a:solidFill>
+                <a:latin typeface="Times New Roman"/>
+              </a:rPr>
+              <a:t>FastAPI + SQLite</a:t>
+            </a:r>
+          </a:p>
+        </p:txBody>
+      </p:sp>
+      <p:sp>
+        <p:nvSpPr>
+          <p:cNvPr id="17" name="Right Arrow 16"/>
+          <p:cNvSpPr/>
+          <p:nvPr/>
+        </p:nvSpPr>
+        <p:spPr>
+          <a:xfrm>
+            <a:off x="8302752" y="7274052"/>
+            <a:ext cx="539496" cy="402336"/>
+          </a:xfrm>
+          <a:prstGeom prst="rightArrow">
+            <a:avLst/>
+          </a:prstGeom>
+          <a:solidFill>
+            <a:srgbClr val="1757AC"/>
+          </a:solidFill>
+          <a:ln>
+            <a:noFill/>
+          </a:ln>
+        </p:spPr>
+        <p:style>
+          <a:lnRef idx="1">
+            <a:schemeClr val="accent1"/>
+          </a:lnRef>
+          <a:fillRef idx="3">
+            <a:schemeClr val="accent1"/>
+          </a:fillRef>
+          <a:effectRef idx="2">
+            <a:schemeClr val="accent1"/>
+          </a:effectRef>
+          <a:fontRef idx="minor">
+            <a:schemeClr val="lt1"/>
+          </a:fontRef>
+        </p:style>
+        <p:txBody>
+          <a:bodyPr rtlCol="0" anchor="ctr"/>
+          <a:lstStyle/>
+          <a:p>
+            <a:pPr algn="ctr"/>
+          </a:p>
+        </p:txBody>
+      </p:sp>
+      <p:sp>
+        <p:nvSpPr>
+          <p:cNvPr id="18" name="Rounded Rectangle 17"/>
+          <p:cNvSpPr/>
+          <p:nvPr/>
+        </p:nvSpPr>
+        <p:spPr>
+          <a:xfrm>
+            <a:off x="8915400" y="6355080"/>
+            <a:ext cx="3246120" cy="2240280"/>
+          </a:xfrm>
+          <a:prstGeom prst="roundRect">
+            <a:avLst/>
+          </a:prstGeom>
+          <a:solidFill>
+            <a:srgbClr val="FFFFFF"/>
+          </a:solidFill>
+          <a:ln w="28575">
+            <a:solidFill>
+              <a:srgbClr val="1757AC"/>
+            </a:solidFill>
+          </a:ln>
+        </p:spPr>
+        <p:style>
+          <a:lnRef idx="1">
+            <a:schemeClr val="accent1"/>
+          </a:lnRef>
+          <a:fillRef idx="3">
+            <a:schemeClr val="accent1"/>
+          </a:fillRef>
+          <a:effectRef idx="2">
+            <a:schemeClr val="accent1"/>
+          </a:effectRef>
+          <a:fontRef idx="minor">
+            <a:schemeClr val="lt1"/>
+          </a:fontRef>
+        </p:style>
+        <p:txBody>
+          <a:bodyPr rtlCol="0" anchor="ctr" wrap="square"/>
+          <a:lstStyle/>
+          <a:p>
+            <a:pPr algn="ctr"/>
+            <a:r>
+              <a:rPr sz="2000" b="1">
+                <a:solidFill>
+                  <a:srgbClr val="1757AC"/>
+                </a:solidFill>
+                <a:latin typeface="Times New Roman"/>
+              </a:rPr>
+              <a:t>SCORE</a:t>
+            </a:r>
+          </a:p>
+          <a:p>
+            <a:pPr algn="ctr">
+              <a:spcBef>
+                <a:spcPts val="600"/>
+              </a:spcBef>
+            </a:pPr>
+            <a:r>
+              <a:rPr sz="1500">
+                <a:solidFill>
+                  <a:srgbClr val="000000"/>
+                </a:solidFill>
+                <a:latin typeface="Times New Roman"/>
+              </a:rPr>
+              <a:t>AttentionLSTM 0–100</a:t>
+            </a:r>
+          </a:p>
+        </p:txBody>
+      </p:sp>
+      <p:sp>
+        <p:nvSpPr>
+          <p:cNvPr id="19" name="Right Arrow 18"/>
+          <p:cNvSpPr/>
+          <p:nvPr/>
+        </p:nvSpPr>
+        <p:spPr>
+          <a:xfrm>
+            <a:off x="12234672" y="7274052"/>
+            <a:ext cx="539496" cy="402336"/>
+          </a:xfrm>
+          <a:prstGeom prst="rightArrow">
+            <a:avLst/>
+          </a:prstGeom>
+          <a:solidFill>
+            <a:srgbClr val="1757AC"/>
+          </a:solidFill>
+          <a:ln>
+            <a:noFill/>
+          </a:ln>
+        </p:spPr>
+        <p:style>
+          <a:lnRef idx="1">
+            <a:schemeClr val="accent1"/>
+          </a:lnRef>
+          <a:fillRef idx="3">
+            <a:schemeClr val="accent1"/>
+          </a:fillRef>
+          <a:effectRef idx="2">
+            <a:schemeClr val="accent1"/>
+          </a:effectRef>
+          <a:fontRef idx="minor">
+            <a:schemeClr val="lt1"/>
+          </a:fontRef>
+        </p:style>
+        <p:txBody>
+          <a:bodyPr rtlCol="0" anchor="ctr"/>
+          <a:lstStyle/>
+          <a:p>
+            <a:pPr algn="ctr"/>
+          </a:p>
+        </p:txBody>
+      </p:sp>
+      <p:sp>
+        <p:nvSpPr>
+          <p:cNvPr id="20" name="Rounded Rectangle 19"/>
+          <p:cNvSpPr/>
+          <p:nvPr/>
+        </p:nvSpPr>
+        <p:spPr>
+          <a:xfrm>
+            <a:off x="12847320" y="6355080"/>
+            <a:ext cx="3246120" cy="2240280"/>
+          </a:xfrm>
+          <a:prstGeom prst="roundRect">
+            <a:avLst/>
+          </a:prstGeom>
+          <a:solidFill>
+            <a:srgbClr val="FFFFFF"/>
+          </a:solidFill>
+          <a:ln w="28575">
+            <a:solidFill>
+              <a:srgbClr val="1757AC"/>
+            </a:solidFill>
+          </a:ln>
+        </p:spPr>
+        <p:style>
+          <a:lnRef idx="1">
+            <a:schemeClr val="accent1"/>
+          </a:lnRef>
+          <a:fillRef idx="3">
+            <a:schemeClr val="accent1"/>
+          </a:fillRef>
+          <a:effectRef idx="2">
+            <a:schemeClr val="accent1"/>
+          </a:effectRef>
+          <a:fontRef idx="minor">
+            <a:schemeClr val="lt1"/>
+          </a:fontRef>
+        </p:style>
+        <p:txBody>
+          <a:bodyPr rtlCol="0" anchor="ctr" wrap="square"/>
+          <a:lstStyle/>
+          <a:p>
+            <a:pPr algn="ctr"/>
+            <a:r>
+              <a:rPr sz="2000" b="1">
+                <a:solidFill>
+                  <a:srgbClr val="1757AC"/>
+                </a:solidFill>
+                <a:latin typeface="Times New Roman"/>
+              </a:rPr>
+              <a:t>ACT</a:t>
+            </a:r>
+          </a:p>
+          <a:p>
+            <a:pPr algn="ctr">
+              <a:spcBef>
+                <a:spcPts val="600"/>
+              </a:spcBef>
+            </a:pPr>
+            <a:r>
+              <a:rPr sz="1500">
+                <a:solidFill>
+                  <a:srgbClr val="000000"/>
+                </a:solidFill>
+                <a:latin typeface="Times New Roman"/>
+              </a:rPr>
+              <a:t>Dashboard + alerts</a:t>
             </a:r>
           </a:p>
         </p:txBody>
@@ -4267,7 +4655,7 @@
                 </a:solidFill>
                 <a:latin typeface="Times New Roman"/>
               </a:rPr>
-              <a:t>Perform calibration, decision-curve analysis, and prospective evaluation with clinical collaborators.</a:t>
+              <a:t>Calibration + decision-curve analysis for bedside thresholds.</a:t>
             </a:r>
           </a:p>
           <a:p>
@@ -4288,7 +4676,7 @@
                 </a:solidFill>
                 <a:latin typeface="Times New Roman"/>
               </a:rPr>
-              <a:t>Add robust missing-data handling and test performance across hospitals and patient subgroups.</a:t>
+              <a:t>Subgroup and fairness validation across age, sex, and hospitals.</a:t>
             </a:r>
           </a:p>
           <a:p>
@@ -4309,7 +4697,7 @@
                 </a:solidFill>
                 <a:latin typeface="Times New Roman"/>
               </a:rPr>
-              <a:t>Compare attention-LSTM with transformer and graph-based temporal models.</a:t>
+              <a:t>Edge/TinyML deployment for wearable live vitals.</a:t>
             </a:r>
           </a:p>
           <a:p>
@@ -4330,7 +4718,7 @@
                 </a:solidFill>
                 <a:latin typeface="Times New Roman"/>
               </a:rPr>
-              <a:t>Explore multimodal fusion with clinical notes and safer integration with real bedside data streams.</a:t>
+              <a:t>Prospective clinical pilot with collaborators.</a:t>
             </a:r>
           </a:p>
           <a:p>
@@ -4351,7 +4739,7 @@
                 </a:solidFill>
                 <a:latin typeface="Times New Roman"/>
               </a:rPr>
-              <a:t>Investigate privacy-preserving and edge-assisted deployment only after clinical validation.</a:t>
+              <a:t>Privacy-preserving multi-hospital training.</a:t>
             </a:r>
           </a:p>
         </p:txBody>
@@ -4763,8 +5151,8 @@
               <a:buChar char="•"/>
             </a:pPr>
             <a:r>
-              <a:rPr/>
-              <a:t>[1] Y. Wang, Y. Bai, and G. Jin, Explainable Deep-Learning Models..., Frontiers in Physiology, vol. 17, 2026.</a:t>
+              <a:rPr sz="1300"/>
+              <a:t>[1] Zheng et al. (2025). Development and Validation of a Dynamic Real-Time Risk Prediction Model for ICU Patients Based on Longitudinal Irregular Data. JMIR 27, e69293. doi:10.2196/69293</a:t>
             </a:r>
           </a:p>
           <a:p>
@@ -4779,8 +5167,8 @@
               <a:buChar char="•"/>
             </a:pPr>
             <a:r>
-              <a:rPr/>
-              <a:t>[2] Z. Yan et al., Deep learning-based in-hospital mortality prediction..., PeerJ, vol. 14, e21631, 2026.</a:t>
+              <a:rPr sz="1300"/>
+              <a:t>[2] Wang, Bai &amp; Jin (2026). Explainable Deep-Learning Models for ICU Outcomes. Frontiers in Physiology 17.</a:t>
             </a:r>
           </a:p>
           <a:p>
@@ -4795,8 +5183,8 @@
               <a:buChar char="•"/>
             </a:pPr>
             <a:r>
-              <a:rPr/>
-              <a:t>[3] B. Sadanandan, Multimodal Deep Learning for Early Prediction..., arXiv:2603.14719, 2026.</a:t>
+              <a:rPr sz="1300"/>
+              <a:t>[3] Yan et al. (2026). Deep Learning-Based In-Hospital Mortality Prediction Using Long-Term Sequential Data in ICU Patients. PeerJ 14, e21631.</a:t>
             </a:r>
           </a:p>
           <a:p>
@@ -4811,8 +5199,8 @@
               <a:buChar char="•"/>
             </a:pPr>
             <a:r>
-              <a:rPr/>
-              <a:t>[4] Y. Wu et al., Revisiting the potential value of vital signs..., Journal of Big Data, vol. 11, no. 40, 2024.</a:t>
+              <a:rPr sz="1300"/>
+              <a:t>[4] Sadanandan (2026). Multimodal Deep Learning for Early Prediction of Patient Deterioration in the ICU. arXiv:2603.14719.</a:t>
             </a:r>
           </a:p>
           <a:p>
@@ -4827,8 +5215,8 @@
               <a:buChar char="•"/>
             </a:pPr>
             <a:r>
-              <a:rPr/>
-              <a:t>[5] P. Xie et al., Unlocking real-time ICU mortality prediction..., npj Digital Medicine, vol. 8, 733, 2025.</a:t>
+              <a:rPr sz="1300"/>
+              <a:t>[5] Wu et al. (2024). Revisiting the Potential Value of Vital Signs in Real-Time Prediction of Mortality Risk in ICU Patients. J Big Data 11, 40.</a:t>
             </a:r>
           </a:p>
           <a:p>
@@ -4843,8 +5231,8 @@
               <a:buChar char="•"/>
             </a:pPr>
             <a:r>
-              <a:rPr/>
-              <a:t>[6] E. Choi et al., Deep Interpretable Early Warning System..., IEEE JBHI, vol. 24, no. 9, 2020.</a:t>
+              <a:rPr sz="1300"/>
+              <a:t>[6] Xie et al. (2025). Unlocking Real-Time ICU Mortality Prediction: RealMIP Continuous Data Recovery. npj Digital Medicine 8, 733.</a:t>
             </a:r>
           </a:p>
           <a:p>
@@ -4859,8 +5247,8 @@
               <a:buChar char="•"/>
             </a:pPr>
             <a:r>
-              <a:rPr/>
-              <a:t>[7] M. R. Scheid et al., Clinical wearable deep learning based deterioration prediction..., Nature Communications, vol. 16, 9513, 2025.</a:t>
+              <a:rPr sz="1300"/>
+              <a:t>[7] Choi et al. (2020). Deep Interpretable Early Warning System for Clinical Deterioration. IEEE JBHI 24(9).</a:t>
             </a:r>
           </a:p>
           <a:p>
@@ -4875,8 +5263,18 @@
               <a:buChar char="•"/>
             </a:pPr>
             <a:r>
-              <a:rPr/>
-              <a:t>[8] PhysioNet, Computing in Cardiology Challenge 2012, physionet.org/content/challenge-2012/.</a:t>
+              <a:rPr sz="1300"/>
+              <a:t>[8] Li et al. (2025). Attention Residual LSTM-FCN for Clinical Time-Series Prediction. IEEE Access 13.</a:t>
+            </a:r>
+          </a:p>
+          <a:p>
+            <a:r>
+              <a:t>[9] Scheid et al. (2025). Wearable Deep Learning for Continuous In-Hospital Deterioration Prediction. Nature Communications 16, 9513.</a:t>
+            </a:r>
+          </a:p>
+          <a:p>
+            <a:r>
+              <a:t>[10] PhysioNet Challenge 2012. Predicting Mortality of ICU Patients. physionet.org/content/challenge-2012/</a:t>
             </a:r>
           </a:p>
         </p:txBody>
@@ -5246,7 +5644,7 @@
                 </a:solidFill>
                 <a:latin typeface="Times New Roman"/>
               </a:rPr>
-              <a:t>Clinicians need an early-warning aid that processes recent patient history and presents understandable reasons for its risk score.</a:t>
+              <a:t>Need: an early-warning aid reading recent history, with understandable reasons.</a:t>
             </a:r>
           </a:p>
           <a:p>
@@ -6130,7 +6528,7 @@
                 </a:solidFill>
                 <a:latin typeface="Times New Roman"/>
               </a:rPr>
-              <a:t>Limitation: retrospective data till discharge; AUROC rises to 98.9 at discharge (hindsight bias). SynCura fixes this with 90-min only, no future info.</a:t>
+              <a:t>Limitation: retrospective data till discharge; AUROC rises to 0.989 at discharge (hindsight bias). SynCura fixes this with 90-min only, no future info.</a:t>
             </a:r>
           </a:p>
         </p:txBody>
@@ -6369,7 +6767,7 @@
                 </a:solidFill>
                 <a:latin typeface="Times New Roman"/>
               </a:rPr>
-              <a:t>Different/better - learns from mistakes: confirmed misses/false alarms queue into weighted retraining.</a:t>
+              <a:t>Design goal - learns from mistakes: confirmed misses/false alarms queue into weighted retraining.</a:t>
             </a:r>
           </a:p>
         </p:txBody>
@@ -7307,7 +7705,7 @@
                 </a:solidFill>
                 <a:latin typeface="Times New Roman"/>
               </a:rPr>
-              <a:t>Investigate earlier warning relative to the NEWS2 baseline, measured properly.</a:t>
+              <a:t>Investigate earlier warning relative to the NEWS2 baseline, via quantified lead time.</a:t>
             </a:r>
           </a:p>
           <a:p>
@@ -7481,8 +7879,8 @@
         </p:nvSpPr>
         <p:spPr>
           <a:xfrm>
-            <a:off x="990295" y="3261665"/>
-            <a:ext cx="16303752" cy="6035040"/>
+            <a:off x="987552" y="3566160"/>
+            <a:ext cx="8229600" cy="3840480"/>
           </a:xfrm>
           <a:prstGeom prst="rect">
             <a:avLst/>
@@ -7510,7 +7908,7 @@
                 </a:solidFill>
                 <a:latin typeface="Times New Roman"/>
               </a:rPr>
-              <a:t>Deployed ensemble: 0.840 validation AUC and 0.844 AUC on the fresh unseen 20% set-B holdout.</a:t>
+              <a:t>Ensemble s48+c93+s45: val 0.840, fresh holdout 0.844.</a:t>
             </a:r>
           </a:p>
           <a:p>
@@ -7522,7 +7920,7 @@
                 </a:solidFill>
                 <a:latin typeface="Times New Roman"/>
               </a:rPr>
-              <a:t>Holdout performance exceeds validation performance, indicating no overfitting to the validation split.</a:t>
+              <a:t>Full metrics: sensitivity, precision, false alarms, lead time vs NEWS2.</a:t>
             </a:r>
           </a:p>
           <a:p>
@@ -7534,23 +7932,35 @@
                 </a:solidFill>
                 <a:latin typeface="Times New Roman"/>
               </a:rPr>
-              <a:t>Evaluation also reports sensitivity, specificity, precision, false-alarm count, and lead-time estimate, benchmarked against the NEWS2 baseline.</a:t>
-            </a:r>
-          </a:p>
-          <a:p>
-            <a:pPr/>
-            <a:r>
-              <a:rPr sz="2100">
-                <a:solidFill>
-                  <a:srgbClr val="000000"/>
-                </a:solidFill>
-                <a:latin typeface="Times New Roman"/>
-              </a:rPr>
-              <a:t>Next evaluation steps: calibration, threshold analysis, and prospective validation before clinical use.</a:t>
-            </a:r>
-          </a:p>
-        </p:txBody>
-      </p:sp>
+              <a:t>Holdout ≥ val suggests no major overfit (CIs pending).</a:t>
+            </a:r>
+          </a:p>
+        </p:txBody>
+      </p:sp>
+      <p:pic>
+        <p:nvPicPr>
+          <p:cNvPr id="7" name="Picture 6" descr="val_fig.png"/>
+          <p:cNvPicPr>
+            <a:picLocks noChangeAspect="1"/>
+          </p:cNvPicPr>
+          <p:nvPr/>
+        </p:nvPicPr>
+        <p:blipFill>
+          <a:blip r:embed="rId4"/>
+          <a:stretch>
+            <a:fillRect/>
+          </a:stretch>
+        </p:blipFill>
+        <p:spPr>
+          <a:xfrm>
+            <a:off x="9692640" y="3566160"/>
+            <a:ext cx="7589520" cy="3438144"/>
+          </a:xfrm>
+          <a:prstGeom prst="rect">
+            <a:avLst/>
+          </a:prstGeom>
+        </p:spPr>
+      </p:pic>
     </p:spTree>
   </p:cSld>
   <p:clrMapOvr>

</xml_diff>